<commit_message>
Add repository link to slides
</commit_message>
<xml_diff>
--- a/slides.pptx
+++ b/slides.pptx
@@ -452,12 +452,16 @@
               <a:t>Open demo1_mcp/01_mcp_demo.ipynb in Jupyter and select the ivado-lab Python 3.12 kernel.</a:t>
             </a:r>
           </a:p>
-          <a:p>
-            <a:endParaRPr/>
-          </a:p>
+          <a:p/>
           <a:p>
             <a:r>
               <a:t>We will go cell by cell. I will not explain every line of Python, only what each cell shows about the protocol.</a:t>
+            </a:r>
+          </a:p>
+          <a:p/>
+          <a:p>
+            <a:r>
+              <a:t>Repo for students: https://github.com/jackwu502/ivado-protocol</a:t>
             </a:r>
           </a:p>
         </p:txBody>
@@ -4490,6 +4494,41 @@
                 </a:solidFill>
               </a:rPr>
               <a:t>Interrupt with questions at any time.</a:t>
+            </a:r>
+          </a:p>
+        </p:txBody>
+      </p:sp>
+      <p:sp>
+        <p:nvSpPr>
+          <p:cNvPr id="5" name="TextBox 4"/>
+          <p:cNvSpPr txBox="1"/>
+          <p:nvPr/>
+        </p:nvSpPr>
+        <p:spPr>
+          <a:xfrm>
+            <a:off x="548640" y="5074920"/>
+            <a:ext cx="11064240" cy="502920"/>
+          </a:xfrm>
+          <a:prstGeom prst="rect">
+            <a:avLst/>
+          </a:prstGeom>
+          <a:noFill/>
+        </p:spPr>
+        <p:txBody>
+          <a:bodyPr wrap="square" anchor="ctr">
+            <a:spAutoFit/>
+          </a:bodyPr>
+          <a:lstStyle/>
+          <a:p>
+            <a:pPr algn="l"/>
+            <a:r>
+              <a:rPr sz="2000" b="1">
+                <a:solidFill>
+                  <a:srgbClr val="1A4D8F"/>
+                </a:solidFill>
+                <a:hlinkClick r:id="rId3"/>
+              </a:rPr>
+              <a:t>Try the demos: github.com/jackwu502/ivado-protocol</a:t>
             </a:r>
           </a:p>
         </p:txBody>

</xml_diff>